<commit_message>
Present CIDR/network design as the solution, not a revision
</commit_message>
<xml_diff>
--- a/final/Skylo-Regional-Hub-Interview-Deck.pptx
+++ b/final/Skylo-Regional-Hub-Interview-Deck.pptx
@@ -16,10 +16,9 @@
     <p:sldId id="264" r:id="rId10"/>
     <p:sldId id="265" r:id="rId11"/>
     <p:sldId id="266" r:id="rId12"/>
-    <p:sldId id="267" r:id="rId13"/>
   </p:sldIdLst>
   <p:notesMasterIdLst>
-    <p:notesMasterId r:id="rId14"/>
+    <p:notesMasterId r:id="rId13"/>
   </p:notesMasterIdLst>
   <p:sldSz cx="12192000" cy="6858000"/>
   <p:notesSz cx="6858000" cy="12192000"/>
@@ -713,94 +712,6 @@
             <a:fld id="{F7021451-1387-4CA6-816F-3879F97B5CBC}" type="slidenum">
               <a:rPr lang="en-US"/>
               <a:t>11</a:t>
-            </a:fld>
-            <a:endParaRPr lang="en-US"/>
-          </a:p>
-        </p:txBody>
-      </p:sp>
-    </p:spTree>
-    <p:extLst>
-      <p:ext uri="{BB962C8B-B14F-4D97-AF65-F5344CB8AC3E}">
-        <p14:creationId xmlns:p14="http://schemas.microsoft.com/office/powerpoint/2010/main" val="1024086991"/>
-      </p:ext>
-    </p:extLst>
-  </p:cSld>
-  <p:clrMapOvr>
-    <a:masterClrMapping/>
-  </p:clrMapOvr>
-</p:notes>
-</file>
-
-<file path=ppt/notesSlides/notesSlide12.xml><?xml version="1.0" encoding="utf-8"?>
-<p:notes xmlns:a="http://schemas.openxmlformats.org/drawingml/2006/main" xmlns:r="http://schemas.openxmlformats.org/officeDocument/2006/relationships" xmlns:p="http://schemas.openxmlformats.org/presentationml/2006/main">
-  <p:cSld>
-    <p:spTree>
-      <p:nvGrpSpPr>
-        <p:cNvPr id="1" name=""/>
-        <p:cNvGrpSpPr/>
-        <p:nvPr/>
-      </p:nvGrpSpPr>
-      <p:grpSpPr>
-        <a:xfrm>
-          <a:off x="0" y="0"/>
-          <a:ext cx="0" cy="0"/>
-          <a:chOff x="0" y="0"/>
-          <a:chExt cx="0" cy="0"/>
-        </a:xfrm>
-      </p:grpSpPr>
-      <p:sp>
-        <p:nvSpPr>
-          <p:cNvPr id="2" name="Slide Image Placeholder 1"/>
-          <p:cNvSpPr>
-            <a:spLocks noGrp="1" noRot="1" noChangeAspect="1"/>
-          </p:cNvSpPr>
-          <p:nvPr>
-            <p:ph type="sldImg"/>
-          </p:nvPr>
-        </p:nvSpPr>
-        <p:spPr/>
-      </p:sp>
-      <p:sp>
-        <p:nvSpPr>
-          <p:cNvPr id="3" name="Notes Placeholder 2"/>
-          <p:cNvSpPr>
-            <a:spLocks noGrp="1"/>
-          </p:cNvSpPr>
-          <p:nvPr>
-            <p:ph type="body" idx="1"/>
-          </p:nvPr>
-        </p:nvSpPr>
-        <p:spPr/>
-        <p:txBody>
-          <a:bodyPr/>
-          <a:lstStyle/>
-          <a:p>
-            <a:r>
-              <a:rPr lang="en-US" dirty="0"/>
-              <a:t/>
-            </a:r>
-            <a:endParaRPr lang="en-US" dirty="0"/>
-          </a:p>
-        </p:txBody>
-      </p:sp>
-      <p:sp>
-        <p:nvSpPr>
-          <p:cNvPr id="4" name="Slide Number Placeholder 3"/>
-          <p:cNvSpPr>
-            <a:spLocks noGrp="1"/>
-          </p:cNvSpPr>
-          <p:nvPr>
-            <p:ph type="sldNum" sz="quarter" idx="10"/>
-          </p:nvPr>
-        </p:nvSpPr>
-        <p:spPr/>
-        <p:txBody>
-          <a:bodyPr/>
-          <a:lstStyle/>
-          <a:p>
-            <a:fld id="{F7021451-1387-4CA6-816F-3879F97B5CBC}" type="slidenum">
-              <a:rPr lang="en-US"/>
-              <a:t>12</a:t>
             </a:fld>
             <a:endParaRPr lang="en-US"/>
           </a:p>
@@ -2098,7 +2009,7 @@
                 <a:ea typeface="Calibri" pitchFamily="34" charset="-122"/>
                 <a:cs typeface="Calibri" pitchFamily="34" charset="-120"/>
               </a:rPr>
-              <a:t>REVISION NOTES</a:t>
+              <a:t>SCOPE, AND WHAT I EXPECT TO DEFEND</a:t>
             </a:r>
             <a:endParaRPr lang="en-US" sz="1200" dirty="0"/>
           </a:p>
@@ -2137,7 +2048,7 @@
                 <a:ea typeface="Cambria" pitchFamily="34" charset="-122"/>
                 <a:cs typeface="Cambria" pitchFamily="34" charset="-120"/>
               </a:rPr>
-              <a:t>What changed from the earlier draft, and why</a:t>
+              <a:t>Ready for the first 30 minutes</a:t>
             </a:r>
             <a:endParaRPr lang="en-US" sz="2800" dirty="0"/>
           </a:p>
@@ -2151,20 +2062,20 @@
         </p:nvSpPr>
         <p:spPr>
           <a:xfrm>
-            <a:off x="548640" y="1463040"/>
-            <a:ext cx="11091672" cy="1051560"/>
+            <a:off x="548640" y="1417320"/>
+            <a:ext cx="5440680" cy="4800600"/>
           </a:xfrm>
           <a:prstGeom prst="roundRect">
             <a:avLst>
-              <a:gd name="adj" fmla="val 6957"/>
+              <a:gd name="adj" fmla="val 1905"/>
             </a:avLst>
           </a:prstGeom>
           <a:solidFill>
-            <a:srgbClr val="FBFCFE"/>
+            <a:srgbClr val="F4F6FB"/>
           </a:solidFill>
           <a:ln w="12700">
             <a:solidFill>
-              <a:srgbClr val="E2E8F0"/>
+              <a:srgbClr val="F4F6FB"/>
             </a:solidFill>
             <a:prstDash val="solid"/>
           </a:ln>
@@ -2178,8 +2089,47 @@
         </p:nvSpPr>
         <p:spPr>
           <a:xfrm>
-            <a:off x="777240" y="1572768"/>
-            <a:ext cx="2103120" cy="822960"/>
+            <a:off x="822960" y="1645920"/>
+            <a:ext cx="4846320" cy="320040"/>
+          </a:xfrm>
+          <a:prstGeom prst="rect">
+            <a:avLst/>
+          </a:prstGeom>
+          <a:noFill/>
+          <a:ln/>
+        </p:spPr>
+        <p:txBody>
+          <a:bodyPr wrap="square" lIns="0" tIns="0" rIns="0" bIns="0" rtlCol="0" anchor="ctr"/>
+          <a:lstStyle/>
+          <a:p>
+            <a:pPr indent="0" marL="0">
+              <a:buNone/>
+            </a:pPr>
+            <a:r>
+              <a:rPr lang="en-US" sz="1400" b="1" dirty="0">
+                <a:solidFill>
+                  <a:srgbClr val="1E2761"/>
+                </a:solidFill>
+                <a:latin typeface="Calibri" pitchFamily="34" charset="0"/>
+                <a:ea typeface="Calibri" pitchFamily="34" charset="-122"/>
+                <a:cs typeface="Calibri" pitchFamily="34" charset="-120"/>
+              </a:rPr>
+              <a:t>Deliberately out of scope here</a:t>
+            </a:r>
+            <a:endParaRPr lang="en-US" sz="1400" dirty="0"/>
+          </a:p>
+        </p:txBody>
+      </p:sp>
+      <p:sp>
+        <p:nvSpPr>
+          <p:cNvPr id="6" name="Text 4"/>
+          <p:cNvSpPr txBox="1"/>
+          <p:nvPr/>
+        </p:nvSpPr>
+        <p:spPr>
+          <a:xfrm>
+            <a:off x="822960" y="2011680"/>
+            <a:ext cx="4846320" cy="1463040"/>
           </a:xfrm>
           <a:prstGeom prst="rect">
             <a:avLst/>
@@ -2193,35 +2143,35 @@
           <a:p>
             <a:pPr indent="0" marL="0">
               <a:lnSpc>
-                <a:spcPct val="110000"/>
+                <a:spcPct val="125000"/>
               </a:lnSpc>
               <a:buNone/>
             </a:pPr>
             <a:r>
-              <a:rPr lang="en-US" sz="1300" b="1" dirty="0">
-                <a:solidFill>
-                  <a:srgbClr val="1E2761"/>
-                </a:solidFill>
-                <a:latin typeface="Calibri" pitchFamily="34" charset="0"/>
-                <a:ea typeface="Calibri" pitchFamily="34" charset="-122"/>
-                <a:cs typeface="Calibri" pitchFamily="34" charset="-120"/>
-              </a:rPr>
-              <a:t>CIDR collision</a:t>
-            </a:r>
-            <a:endParaRPr lang="en-US" sz="1300" dirty="0"/>
-          </a:p>
-        </p:txBody>
-      </p:sp>
-      <p:sp>
-        <p:nvSpPr>
-          <p:cNvPr id="6" name="Text 4"/>
-          <p:cNvSpPr txBox="1"/>
-          <p:nvPr/>
-        </p:nvSpPr>
-        <p:spPr>
-          <a:xfrm>
-            <a:off x="3017520" y="1572768"/>
-            <a:ext cx="3840480" cy="822960"/>
+              <a:rPr lang="en-US" sz="1200" dirty="0">
+                <a:solidFill>
+                  <a:srgbClr val="1F2430"/>
+                </a:solidFill>
+                <a:latin typeface="Calibri" pitchFamily="34" charset="0"/>
+                <a:ea typeface="Calibri" pitchFamily="34" charset="-122"/>
+                <a:cs typeface="Calibri" pitchFamily="34" charset="-120"/>
+              </a:rPr>
+              <a:t>Region-loss DR (RTO/RPO target and its cost). Single-AZ resilience is the named constraint and is built into the network/compute design already — that's not DR, it's the baseline. Region failover is a real follow-up question with a verbal answer ready; it's kept out of the written artifact so it stays focused on what's asked.</a:t>
+            </a:r>
+            <a:endParaRPr lang="en-US" sz="1200" dirty="0"/>
+          </a:p>
+        </p:txBody>
+      </p:sp>
+      <p:sp>
+        <p:nvSpPr>
+          <p:cNvPr id="7" name="Text 5"/>
+          <p:cNvSpPr txBox="1"/>
+          <p:nvPr/>
+        </p:nvSpPr>
+        <p:spPr>
+          <a:xfrm>
+            <a:off x="822960" y="3611880"/>
+            <a:ext cx="4846320" cy="914400"/>
           </a:xfrm>
           <a:prstGeom prst="rect">
             <a:avLst/>
@@ -2235,64 +2185,22 @@
           <a:p>
             <a:pPr indent="0" marL="0">
               <a:lnSpc>
-                <a:spcPct val="115000"/>
+                <a:spcPct val="125000"/>
               </a:lnSpc>
               <a:buNone/>
             </a:pPr>
             <a:r>
-              <a:rPr lang="en-US" sz="1050" dirty="0">
-                <a:solidFill>
-                  <a:srgbClr val="9A3412"/>
-                </a:solidFill>
-                <a:latin typeface="Calibri" pitchFamily="34" charset="0"/>
-                <a:ea typeface="Calibri" pitchFamily="34" charset="-122"/>
-                <a:cs typeface="Calibri" pitchFamily="34" charset="-120"/>
-              </a:rPr>
-              <a:t>10.96.0.0/11 overlapped the hub's own 10.100.0.0/16.</a:t>
-            </a:r>
-            <a:endParaRPr lang="en-US" sz="1050" dirty="0"/>
-          </a:p>
-        </p:txBody>
-      </p:sp>
-      <p:sp>
-        <p:nvSpPr>
-          <p:cNvPr id="7" name="Text 5"/>
-          <p:cNvSpPr txBox="1"/>
-          <p:nvPr/>
-        </p:nvSpPr>
-        <p:spPr>
-          <a:xfrm>
-            <a:off x="6995160" y="1572768"/>
-            <a:ext cx="4480560" cy="822960"/>
-          </a:xfrm>
-          <a:prstGeom prst="rect">
-            <a:avLst/>
-          </a:prstGeom>
-          <a:noFill/>
-          <a:ln/>
-        </p:spPr>
-        <p:txBody>
-          <a:bodyPr wrap="square" lIns="0" tIns="0" rIns="0" bIns="0" rtlCol="0" anchor="ctr"/>
-          <a:lstStyle/>
-          <a:p>
-            <a:pPr indent="0" marL="0">
-              <a:lnSpc>
-                <a:spcPct val="115000"/>
-              </a:lnSpc>
-              <a:buNone/>
-            </a:pPr>
-            <a:r>
-              <a:rPr lang="en-US" sz="1050" dirty="0">
-                <a:solidFill>
-                  <a:srgbClr val="047857"/>
-                </a:solidFill>
-                <a:latin typeface="Calibri" pitchFamily="34" charset="0"/>
-                <a:ea typeface="Calibri" pitchFamily="34" charset="-122"/>
-                <a:cs typeface="Calibri" pitchFamily="34" charset="-120"/>
-              </a:rPr>
-              <a:t>Three disjoint address families (10.0.0.0/9 / 10.128.0.0/9 / 172.16.0.0/12) — structurally impossible to collide.</a:t>
-            </a:r>
-            <a:endParaRPr lang="en-US" sz="1050" dirty="0"/>
+              <a:rPr lang="en-US" sz="1200" dirty="0">
+                <a:solidFill>
+                  <a:srgbClr val="1F2430"/>
+                </a:solidFill>
+                <a:latin typeface="Calibri" pitchFamily="34" charset="0"/>
+                <a:ea typeface="Calibri" pitchFamily="34" charset="-122"/>
+                <a:cs typeface="Calibri" pitchFamily="34" charset="-120"/>
+              </a:rPr>
+              <a:t>No internal 3GPP sub-function naming (AMF/SMF/UPF) in the diagrams — kept generic as “data-ingress” and “core-network” pods for a simpler conversation.</a:t>
+            </a:r>
+            <a:endParaRPr lang="en-US" sz="1200" dirty="0"/>
           </a:p>
         </p:txBody>
       </p:sp>
@@ -2304,20 +2212,20 @@
         </p:nvSpPr>
         <p:spPr>
           <a:xfrm>
-            <a:off x="548640" y="2651760"/>
-            <a:ext cx="11091672" cy="1051560"/>
+            <a:off x="6199632" y="1417320"/>
+            <a:ext cx="5440680" cy="4800600"/>
           </a:xfrm>
           <a:prstGeom prst="roundRect">
             <a:avLst>
-              <a:gd name="adj" fmla="val 6957"/>
+              <a:gd name="adj" fmla="val 1905"/>
             </a:avLst>
           </a:prstGeom>
           <a:solidFill>
-            <a:srgbClr val="FBFCFE"/>
+            <a:srgbClr val="1E2761"/>
           </a:solidFill>
           <a:ln w="12700">
             <a:solidFill>
-              <a:srgbClr val="E2E8F0"/>
+              <a:srgbClr val="1E2761"/>
             </a:solidFill>
             <a:prstDash val="solid"/>
           </a:ln>
@@ -2331,146 +2239,57 @@
         </p:nvSpPr>
         <p:spPr>
           <a:xfrm>
-            <a:off x="777240" y="2761488"/>
-            <a:ext cx="2103120" cy="822960"/>
-          </a:xfrm>
-          <a:prstGeom prst="rect">
-            <a:avLst/>
-          </a:prstGeom>
-          <a:noFill/>
-          <a:ln/>
-        </p:spPr>
-        <p:txBody>
-          <a:bodyPr wrap="square" lIns="0" tIns="0" rIns="0" bIns="0" rtlCol="0" anchor="ctr"/>
-          <a:lstStyle/>
-          <a:p>
-            <a:pPr indent="0" marL="0">
-              <a:lnSpc>
-                <a:spcPct val="110000"/>
-              </a:lnSpc>
-              <a:buNone/>
-            </a:pPr>
-            <a:r>
-              <a:rPr lang="en-US" sz="1300" b="1" dirty="0">
-                <a:solidFill>
-                  <a:srgbClr val="1E2761"/>
-                </a:solidFill>
-                <a:latin typeface="Calibri" pitchFamily="34" charset="0"/>
-                <a:ea typeface="Calibri" pitchFamily="34" charset="-122"/>
-                <a:cs typeface="Calibri" pitchFamily="34" charset="-120"/>
-              </a:rPr>
-              <a:t>TGW segmentation</a:t>
-            </a:r>
-            <a:endParaRPr lang="en-US" sz="1300" dirty="0"/>
-          </a:p>
-        </p:txBody>
-      </p:sp>
-      <p:sp>
-        <p:nvSpPr>
-          <p:cNvPr id="10" name="Text 8"/>
-          <p:cNvSpPr txBox="1"/>
-          <p:nvPr/>
-        </p:nvSpPr>
-        <p:spPr>
-          <a:xfrm>
-            <a:off x="3017520" y="2761488"/>
-            <a:ext cx="3840480" cy="822960"/>
-          </a:xfrm>
-          <a:prstGeom prst="rect">
-            <a:avLst/>
-          </a:prstGeom>
-          <a:noFill/>
-          <a:ln/>
-        </p:spPr>
-        <p:txBody>
-          <a:bodyPr wrap="square" lIns="0" tIns="0" rIns="0" bIns="0" rtlCol="0" anchor="ctr"/>
-          <a:lstStyle/>
-          <a:p>
-            <a:pPr indent="0" marL="0">
-              <a:lnSpc>
-                <a:spcPct val="115000"/>
-              </a:lnSpc>
-              <a:buNone/>
-            </a:pPr>
-            <a:r>
-              <a:rPr lang="en-US" sz="1050" dirty="0">
-                <a:solidFill>
-                  <a:srgbClr val="9A3412"/>
-                </a:solidFill>
-                <a:latin typeface="Calibri" pitchFamily="34" charset="0"/>
-                <a:ea typeface="Calibri" pitchFamily="34" charset="-122"/>
-                <a:cs typeface="Calibri" pitchFamily="34" charset="-120"/>
-              </a:rPr>
-              <a:t>Ground vs. org traffic separation was asserted in prose, not drawn.</a:t>
-            </a:r>
-            <a:endParaRPr lang="en-US" sz="1050" dirty="0"/>
-          </a:p>
-        </p:txBody>
-      </p:sp>
-      <p:sp>
-        <p:nvSpPr>
-          <p:cNvPr id="11" name="Text 9"/>
-          <p:cNvSpPr txBox="1"/>
-          <p:nvPr/>
-        </p:nvSpPr>
-        <p:spPr>
-          <a:xfrm>
-            <a:off x="6995160" y="2761488"/>
-            <a:ext cx="4480560" cy="822960"/>
-          </a:xfrm>
-          <a:prstGeom prst="rect">
-            <a:avLst/>
-          </a:prstGeom>
-          <a:noFill/>
-          <a:ln/>
-        </p:spPr>
-        <p:txBody>
-          <a:bodyPr wrap="square" lIns="0" tIns="0" rIns="0" bIns="0" rtlCol="0" anchor="ctr"/>
-          <a:lstStyle/>
-          <a:p>
-            <a:pPr indent="0" marL="0">
-              <a:lnSpc>
-                <a:spcPct val="115000"/>
-              </a:lnSpc>
-              <a:buNone/>
-            </a:pPr>
-            <a:r>
-              <a:rPr lang="en-US" sz="1050" dirty="0">
-                <a:solidFill>
-                  <a:srgbClr val="047857"/>
-                </a:solidFill>
-                <a:latin typeface="Calibri" pitchFamily="34" charset="0"/>
-                <a:ea typeface="Calibri" pitchFamily="34" charset="-122"/>
-                <a:cs typeface="Calibri" pitchFamily="34" charset="-120"/>
-              </a:rPr>
-              <a:t>Two explicit route tables on the TGW attachment, shown in the diagram.</a:t>
-            </a:r>
-            <a:endParaRPr lang="en-US" sz="1050" dirty="0"/>
-          </a:p>
-        </p:txBody>
-      </p:sp>
-      <p:sp>
-        <p:nvSpPr>
-          <p:cNvPr id="12" name="Shape 10"/>
+            <a:off x="6492240" y="1645920"/>
+            <a:ext cx="4846320" cy="320040"/>
+          </a:xfrm>
+          <a:prstGeom prst="rect">
+            <a:avLst/>
+          </a:prstGeom>
+          <a:noFill/>
+          <a:ln/>
+        </p:spPr>
+        <p:txBody>
+          <a:bodyPr wrap="square" lIns="0" tIns="0" rIns="0" bIns="0" rtlCol="0" anchor="ctr"/>
+          <a:lstStyle/>
+          <a:p>
+            <a:pPr indent="0" marL="0">
+              <a:buNone/>
+            </a:pPr>
+            <a:r>
+              <a:rPr lang="en-US" sz="1400" b="1" dirty="0">
+                <a:solidFill>
+                  <a:srgbClr val="FFFFFF"/>
+                </a:solidFill>
+                <a:latin typeface="Calibri" pitchFamily="34" charset="0"/>
+                <a:ea typeface="Calibri" pitchFamily="34" charset="-122"/>
+                <a:cs typeface="Calibri" pitchFamily="34" charset="-120"/>
+              </a:rPr>
+              <a:t>Trade-offs I'll defend if pushed</a:t>
+            </a:r>
+            <a:endParaRPr lang="en-US" sz="1400" dirty="0"/>
+          </a:p>
+        </p:txBody>
+      </p:sp>
+      <p:sp>
+        <p:nvSpPr>
+          <p:cNvPr id="10" name="Shape 8"/>
           <p:cNvSpPr/>
           <p:nvPr/>
         </p:nvSpPr>
         <p:spPr>
           <a:xfrm>
-            <a:off x="548640" y="3840480"/>
-            <a:ext cx="11091672" cy="1051560"/>
-          </a:xfrm>
-          <a:prstGeom prst="roundRect">
-            <a:avLst>
-              <a:gd name="adj" fmla="val 6957"/>
-            </a:avLst>
+            <a:off x="6492240" y="2157984"/>
+            <a:ext cx="91440" cy="91440"/>
+          </a:xfrm>
+          <a:prstGeom prst="ellipse">
+            <a:avLst/>
           </a:prstGeom>
           <a:solidFill>
-            <a:srgbClr val="FBFCFE"/>
+            <a:srgbClr val="CADCFC"/>
           </a:solidFill>
           <a:ln w="12700">
             <a:solidFill>
-              <a:srgbClr val="E2E8F0"/>
+              <a:srgbClr val="CADCFC"/>
             </a:solidFill>
             <a:prstDash val="solid"/>
           </a:ln>
@@ -2478,14 +2297,14 @@
       </p:sp>
       <p:sp>
         <p:nvSpPr>
-          <p:cNvPr id="13" name="Text 11"/>
-          <p:cNvSpPr txBox="1"/>
-          <p:nvPr/>
-        </p:nvSpPr>
-        <p:spPr>
-          <a:xfrm>
-            <a:off x="777240" y="3950208"/>
-            <a:ext cx="2103120" cy="822960"/>
+          <p:cNvPr id="11" name="Text 9"/>
+          <p:cNvSpPr txBox="1"/>
+          <p:nvPr/>
+        </p:nvSpPr>
+        <p:spPr>
+          <a:xfrm>
+            <a:off x="6766560" y="2029968"/>
+            <a:ext cx="4709160" cy="777240"/>
           </a:xfrm>
           <a:prstGeom prst="rect">
             <a:avLst/>
@@ -2499,131 +2318,45 @@
           <a:p>
             <a:pPr indent="0" marL="0">
               <a:lnSpc>
-                <a:spcPct val="110000"/>
+                <a:spcPct val="120000"/>
               </a:lnSpc>
               <a:buNone/>
             </a:pPr>
             <a:r>
-              <a:rPr lang="en-US" sz="1300" b="1" dirty="0">
-                <a:solidFill>
-                  <a:srgbClr val="1E2761"/>
-                </a:solidFill>
-                <a:latin typeface="Calibri" pitchFamily="34" charset="0"/>
-                <a:ea typeface="Calibri" pitchFamily="34" charset="-122"/>
-                <a:cs typeface="Calibri" pitchFamily="34" charset="-120"/>
-              </a:rPr>
-              <a:t>Public surface</a:t>
-            </a:r>
-            <a:endParaRPr lang="en-US" sz="1300" dirty="0"/>
-          </a:p>
-        </p:txBody>
-      </p:sp>
-      <p:sp>
-        <p:nvSpPr>
-          <p:cNvPr id="14" name="Text 12"/>
-          <p:cNvSpPr txBox="1"/>
-          <p:nvPr/>
-        </p:nvSpPr>
-        <p:spPr>
-          <a:xfrm>
-            <a:off x="3017520" y="3950208"/>
-            <a:ext cx="3840480" cy="822960"/>
-          </a:xfrm>
-          <a:prstGeom prst="rect">
-            <a:avLst/>
-          </a:prstGeom>
-          <a:noFill/>
-          <a:ln/>
-        </p:spPr>
-        <p:txBody>
-          <a:bodyPr wrap="square" lIns="0" tIns="0" rIns="0" bIns="0" rtlCol="0" anchor="ctr"/>
-          <a:lstStyle/>
-          <a:p>
-            <a:pPr indent="0" marL="0">
-              <a:lnSpc>
-                <a:spcPct val="115000"/>
-              </a:lnSpc>
-              <a:buNone/>
-            </a:pPr>
-            <a:r>
-              <a:rPr lang="en-US" sz="1050" dirty="0">
-                <a:solidFill>
-                  <a:srgbClr val="9A3412"/>
-                </a:solidFill>
-                <a:latin typeface="Calibri" pitchFamily="34" charset="0"/>
-                <a:ea typeface="Calibri" pitchFamily="34" charset="-122"/>
-                <a:cs typeface="Calibri" pitchFamily="34" charset="-120"/>
-              </a:rPr>
-              <a:t>A diagram showed a workload path straight to the internet, bypassing the NLB.</a:t>
-            </a:r>
-            <a:endParaRPr lang="en-US" sz="1050" dirty="0"/>
-          </a:p>
-        </p:txBody>
-      </p:sp>
-      <p:sp>
-        <p:nvSpPr>
-          <p:cNvPr id="15" name="Text 13"/>
-          <p:cNvSpPr txBox="1"/>
-          <p:nvPr/>
-        </p:nvSpPr>
-        <p:spPr>
-          <a:xfrm>
-            <a:off x="6995160" y="3950208"/>
-            <a:ext cx="4480560" cy="822960"/>
-          </a:xfrm>
-          <a:prstGeom prst="rect">
-            <a:avLst/>
-          </a:prstGeom>
-          <a:noFill/>
-          <a:ln/>
-        </p:spPr>
-        <p:txBody>
-          <a:bodyPr wrap="square" lIns="0" tIns="0" rIns="0" bIns="0" rtlCol="0" anchor="ctr"/>
-          <a:lstStyle/>
-          <a:p>
-            <a:pPr indent="0" marL="0">
-              <a:lnSpc>
-                <a:spcPct val="115000"/>
-              </a:lnSpc>
-              <a:buNone/>
-            </a:pPr>
-            <a:r>
-              <a:rPr lang="en-US" sz="1050" dirty="0">
-                <a:solidFill>
-                  <a:srgbClr val="047857"/>
-                </a:solidFill>
-                <a:latin typeface="Calibri" pitchFamily="34" charset="0"/>
-                <a:ea typeface="Calibri" pitchFamily="34" charset="-122"/>
-                <a:cs typeface="Calibri" pitchFamily="34" charset="-120"/>
-              </a:rPr>
-              <a:t>Exactly one public surface: the NLB. Drawn and stated as a hard rule.</a:t>
-            </a:r>
-            <a:endParaRPr lang="en-US" sz="1050" dirty="0"/>
-          </a:p>
-        </p:txBody>
-      </p:sp>
-      <p:sp>
-        <p:nvSpPr>
-          <p:cNvPr id="16" name="Shape 14"/>
+              <a:rPr lang="en-US" sz="1200" dirty="0">
+                <a:solidFill>
+                  <a:srgbClr val="FFFFFF"/>
+                </a:solidFill>
+                <a:latin typeface="Calibri" pitchFamily="34" charset="0"/>
+                <a:ea typeface="Calibri" pitchFamily="34" charset="-122"/>
+                <a:cs typeface="Calibri" pitchFamily="34" charset="-120"/>
+              </a:rPr>
+              <a:t>EKS over ECS — reverses if the workload turns out to be session/control-only.</a:t>
+            </a:r>
+            <a:endParaRPr lang="en-US" sz="1200" dirty="0"/>
+          </a:p>
+        </p:txBody>
+      </p:sp>
+      <p:sp>
+        <p:nvSpPr>
+          <p:cNvPr id="12" name="Shape 10"/>
           <p:cNvSpPr/>
           <p:nvPr/>
         </p:nvSpPr>
         <p:spPr>
           <a:xfrm>
-            <a:off x="548640" y="5029200"/>
-            <a:ext cx="11091672" cy="1051560"/>
-          </a:xfrm>
-          <a:prstGeom prst="roundRect">
-            <a:avLst>
-              <a:gd name="adj" fmla="val 6957"/>
-            </a:avLst>
+            <a:off x="6492240" y="3026664"/>
+            <a:ext cx="91440" cy="91440"/>
+          </a:xfrm>
+          <a:prstGeom prst="ellipse">
+            <a:avLst/>
           </a:prstGeom>
           <a:solidFill>
-            <a:srgbClr val="FBFCFE"/>
+            <a:srgbClr val="CADCFC"/>
           </a:solidFill>
           <a:ln w="12700">
             <a:solidFill>
-              <a:srgbClr val="E2E8F0"/>
+              <a:srgbClr val="CADCFC"/>
             </a:solidFill>
             <a:prstDash val="solid"/>
           </a:ln>
@@ -2631,14 +2364,148 @@
       </p:sp>
       <p:sp>
         <p:nvSpPr>
+          <p:cNvPr id="13" name="Text 11"/>
+          <p:cNvSpPr txBox="1"/>
+          <p:nvPr/>
+        </p:nvSpPr>
+        <p:spPr>
+          <a:xfrm>
+            <a:off x="6766560" y="2898648"/>
+            <a:ext cx="4709160" cy="777240"/>
+          </a:xfrm>
+          <a:prstGeom prst="rect">
+            <a:avLst/>
+          </a:prstGeom>
+          <a:noFill/>
+          <a:ln/>
+        </p:spPr>
+        <p:txBody>
+          <a:bodyPr wrap="square" lIns="0" tIns="0" rIns="0" bIns="0" rtlCol="0" anchor="ctr"/>
+          <a:lstStyle/>
+          <a:p>
+            <a:pPr indent="0" marL="0">
+              <a:lnSpc>
+                <a:spcPct val="120000"/>
+              </a:lnSpc>
+              <a:buNone/>
+            </a:pPr>
+            <a:r>
+              <a:rPr lang="en-US" sz="1200" dirty="0">
+                <a:solidFill>
+                  <a:srgbClr val="FFFFFF"/>
+                </a:solidFill>
+                <a:latin typeface="Calibri" pitchFamily="34" charset="0"/>
+                <a:ea typeface="Calibri" pitchFamily="34" charset="-122"/>
+                <a:cs typeface="Calibri" pitchFamily="34" charset="-120"/>
+              </a:rPr>
+              <a:t>TGW attachment in private subnets, no dedicated tgw-attach tier — reverses on a security review.</a:t>
+            </a:r>
+            <a:endParaRPr lang="en-US" sz="1200" dirty="0"/>
+          </a:p>
+        </p:txBody>
+      </p:sp>
+      <p:sp>
+        <p:nvSpPr>
+          <p:cNvPr id="14" name="Shape 12"/>
+          <p:cNvSpPr/>
+          <p:nvPr/>
+        </p:nvSpPr>
+        <p:spPr>
+          <a:xfrm>
+            <a:off x="6492240" y="3895344"/>
+            <a:ext cx="91440" cy="91440"/>
+          </a:xfrm>
+          <a:prstGeom prst="ellipse">
+            <a:avLst/>
+          </a:prstGeom>
+          <a:solidFill>
+            <a:srgbClr val="CADCFC"/>
+          </a:solidFill>
+          <a:ln w="12700">
+            <a:solidFill>
+              <a:srgbClr val="CADCFC"/>
+            </a:solidFill>
+            <a:prstDash val="solid"/>
+          </a:ln>
+        </p:spPr>
+      </p:sp>
+      <p:sp>
+        <p:nvSpPr>
+          <p:cNvPr id="15" name="Text 13"/>
+          <p:cNvSpPr txBox="1"/>
+          <p:nvPr/>
+        </p:nvSpPr>
+        <p:spPr>
+          <a:xfrm>
+            <a:off x="6766560" y="3767328"/>
+            <a:ext cx="4709160" cy="777240"/>
+          </a:xfrm>
+          <a:prstGeom prst="rect">
+            <a:avLst/>
+          </a:prstGeom>
+          <a:noFill/>
+          <a:ln/>
+        </p:spPr>
+        <p:txBody>
+          <a:bodyPr wrap="square" lIns="0" tIns="0" rIns="0" bIns="0" rtlCol="0" anchor="ctr"/>
+          <a:lstStyle/>
+          <a:p>
+            <a:pPr indent="0" marL="0">
+              <a:lnSpc>
+                <a:spcPct val="120000"/>
+              </a:lnSpc>
+              <a:buNone/>
+            </a:pPr>
+            <a:r>
+              <a:rPr lang="en-US" sz="1200" dirty="0">
+                <a:solidFill>
+                  <a:srgbClr val="FFFFFF"/>
+                </a:solidFill>
+                <a:latin typeface="Calibri" pitchFamily="34" charset="0"/>
+                <a:ea typeface="Calibri" pitchFamily="34" charset="-122"/>
+                <a:cs typeface="Calibri" pitchFamily="34" charset="-120"/>
+              </a:rPr>
+              <a:t>ElastiCache failover claim depends on the client library being cluster-aware — needs confirming.</a:t>
+            </a:r>
+            <a:endParaRPr lang="en-US" sz="1200" dirty="0"/>
+          </a:p>
+        </p:txBody>
+      </p:sp>
+      <p:sp>
+        <p:nvSpPr>
+          <p:cNvPr id="16" name="Shape 14"/>
+          <p:cNvSpPr/>
+          <p:nvPr/>
+        </p:nvSpPr>
+        <p:spPr>
+          <a:xfrm>
+            <a:off x="6492240" y="4764024"/>
+            <a:ext cx="91440" cy="91440"/>
+          </a:xfrm>
+          <a:prstGeom prst="ellipse">
+            <a:avLst/>
+          </a:prstGeom>
+          <a:solidFill>
+            <a:srgbClr val="CADCFC"/>
+          </a:solidFill>
+          <a:ln w="12700">
+            <a:solidFill>
+              <a:srgbClr val="CADCFC"/>
+            </a:solidFill>
+            <a:prstDash val="solid"/>
+          </a:ln>
+        </p:spPr>
+      </p:sp>
+      <p:sp>
+        <p:nvSpPr>
           <p:cNvPr id="17" name="Text 15"/>
           <p:cNvSpPr txBox="1"/>
           <p:nvPr/>
         </p:nvSpPr>
         <p:spPr>
           <a:xfrm>
-            <a:off x="777240" y="5138928"/>
-            <a:ext cx="2103120" cy="822960"/>
+            <a:off x="6766560" y="4636008"/>
+            <a:ext cx="4709160" cy="777240"/>
           </a:xfrm>
           <a:prstGeom prst="rect">
             <a:avLst/>
@@ -2652,112 +2519,28 @@
           <a:p>
             <a:pPr indent="0" marL="0">
               <a:lnSpc>
-                <a:spcPct val="110000"/>
+                <a:spcPct val="120000"/>
               </a:lnSpc>
               <a:buNone/>
             </a:pPr>
             <a:r>
-              <a:rPr lang="en-US" sz="1300" b="1" dirty="0">
-                <a:solidFill>
-                  <a:srgbClr val="1E2761"/>
-                </a:solidFill>
-                <a:latin typeface="Calibri" pitchFamily="34" charset="0"/>
-                <a:ea typeface="Calibri" pitchFamily="34" charset="-122"/>
-                <a:cs typeface="Calibri" pitchFamily="34" charset="-120"/>
-              </a:rPr>
-              <a:t>Latency figures</a:t>
-            </a:r>
-            <a:endParaRPr lang="en-US" sz="1300" dirty="0"/>
+              <a:rPr lang="en-US" sz="1200" dirty="0">
+                <a:solidFill>
+                  <a:srgbClr val="FFFFFF"/>
+                </a:solidFill>
+                <a:latin typeface="Calibri" pitchFamily="34" charset="0"/>
+                <a:ea typeface="Calibri" pitchFamily="34" charset="-122"/>
+                <a:cs typeface="Calibri" pitchFamily="34" charset="-120"/>
+              </a:rPr>
+              <a:t>Single Direct Connect circuit, as scoped — production hardening would add a second circuit.</a:t>
+            </a:r>
+            <a:endParaRPr lang="en-US" sz="1200" dirty="0"/>
           </a:p>
         </p:txBody>
       </p:sp>
       <p:sp>
         <p:nvSpPr>
           <p:cNvPr id="18" name="Text 16"/>
-          <p:cNvSpPr txBox="1"/>
-          <p:nvPr/>
-        </p:nvSpPr>
-        <p:spPr>
-          <a:xfrm>
-            <a:off x="3017520" y="5138928"/>
-            <a:ext cx="3840480" cy="822960"/>
-          </a:xfrm>
-          <a:prstGeom prst="rect">
-            <a:avLst/>
-          </a:prstGeom>
-          <a:noFill/>
-          <a:ln/>
-        </p:spPr>
-        <p:txBody>
-          <a:bodyPr wrap="square" lIns="0" tIns="0" rIns="0" bIns="0" rtlCol="0" anchor="ctr"/>
-          <a:lstStyle/>
-          <a:p>
-            <a:pPr indent="0" marL="0">
-              <a:lnSpc>
-                <a:spcPct val="115000"/>
-              </a:lnSpc>
-              <a:buNone/>
-            </a:pPr>
-            <a:r>
-              <a:rPr lang="en-US" sz="1050" dirty="0">
-                <a:solidFill>
-                  <a:srgbClr val="9A3412"/>
-                </a:solidFill>
-                <a:latin typeface="Calibri" pitchFamily="34" charset="0"/>
-                <a:ea typeface="Calibri" pitchFamily="34" charset="-122"/>
-                <a:cs typeface="Calibri" pitchFamily="34" charset="-120"/>
-              </a:rPr>
-              <a:t>Earlier numbers (“5ms,” “2ms”) were invented, not measured.</a:t>
-            </a:r>
-            <a:endParaRPr lang="en-US" sz="1050" dirty="0"/>
-          </a:p>
-        </p:txBody>
-      </p:sp>
-      <p:sp>
-        <p:nvSpPr>
-          <p:cNvPr id="19" name="Text 17"/>
-          <p:cNvSpPr txBox="1"/>
-          <p:nvPr/>
-        </p:nvSpPr>
-        <p:spPr>
-          <a:xfrm>
-            <a:off x="6995160" y="5138928"/>
-            <a:ext cx="4480560" cy="822960"/>
-          </a:xfrm>
-          <a:prstGeom prst="rect">
-            <a:avLst/>
-          </a:prstGeom>
-          <a:noFill/>
-          <a:ln/>
-        </p:spPr>
-        <p:txBody>
-          <a:bodyPr wrap="square" lIns="0" tIns="0" rIns="0" bIns="0" rtlCol="0" anchor="ctr"/>
-          <a:lstStyle/>
-          <a:p>
-            <a:pPr indent="0" marL="0">
-              <a:lnSpc>
-                <a:spcPct val="115000"/>
-              </a:lnSpc>
-              <a:buNone/>
-            </a:pPr>
-            <a:r>
-              <a:rPr lang="en-US" sz="1050" dirty="0">
-                <a:solidFill>
-                  <a:srgbClr val="047857"/>
-                </a:solidFill>
-                <a:latin typeface="Calibri" pitchFamily="34" charset="0"/>
-                <a:ea typeface="Calibri" pitchFamily="34" charset="-122"/>
-                <a:cs typeface="Calibri" pitchFamily="34" charset="-120"/>
-              </a:rPr>
-              <a:t>Ranges, labeled explicitly as order-of-magnitude estimates — not benchmarks.</a:t>
-            </a:r>
-            <a:endParaRPr lang="en-US" sz="1050" dirty="0"/>
-          </a:p>
-        </p:txBody>
-      </p:sp>
-      <p:sp>
-        <p:nvSpPr>
-          <p:cNvPr id="20" name="Text 18"/>
           <p:cNvSpPr txBox="1"/>
           <p:nvPr/>
         </p:nvSpPr>
@@ -2796,7 +2579,7 @@
       </p:sp>
       <p:sp>
         <p:nvSpPr>
-          <p:cNvPr id="21" name="Text 19"/>
+          <p:cNvPr id="19" name="Text 17"/>
           <p:cNvSpPr txBox="1"/>
           <p:nvPr/>
         </p:nvSpPr>
@@ -2844,678 +2627,6 @@
 <file path=ppt/slides/slide11.xml><?xml version="1.0" encoding="utf-8"?>
 <p:sld xmlns:a="http://schemas.openxmlformats.org/drawingml/2006/main" xmlns:r="http://schemas.openxmlformats.org/officeDocument/2006/relationships" xmlns:p="http://schemas.openxmlformats.org/presentationml/2006/main">
   <p:cSld name="Slide 11">
-    <p:bg>
-      <p:bgPr>
-        <a:solidFill>
-          <a:srgbClr val="FFFFFF"/>
-        </a:solidFill>
-      </p:bgPr>
-    </p:bg>
-    <p:spTree>
-      <p:nvGrpSpPr>
-        <p:cNvPr id="1" name=""/>
-        <p:cNvGrpSpPr/>
-        <p:nvPr/>
-      </p:nvGrpSpPr>
-      <p:grpSpPr>
-        <a:xfrm>
-          <a:off x="0" y="0"/>
-          <a:ext cx="0" cy="0"/>
-          <a:chOff x="0" y="0"/>
-          <a:chExt cx="0" cy="0"/>
-        </a:xfrm>
-      </p:grpSpPr>
-      <p:sp>
-        <p:nvSpPr>
-          <p:cNvPr id="2" name="Text 0"/>
-          <p:cNvSpPr txBox="1"/>
-          <p:nvPr/>
-        </p:nvSpPr>
-        <p:spPr>
-          <a:xfrm>
-            <a:off x="548640" y="320040"/>
-            <a:ext cx="9144000" cy="274320"/>
-          </a:xfrm>
-          <a:prstGeom prst="rect">
-            <a:avLst/>
-          </a:prstGeom>
-          <a:noFill/>
-          <a:ln/>
-        </p:spPr>
-        <p:txBody>
-          <a:bodyPr wrap="square" lIns="0" tIns="0" rIns="0" bIns="0" rtlCol="0" anchor="ctr"/>
-          <a:lstStyle/>
-          <a:p>
-            <a:pPr indent="0" marL="0">
-              <a:buNone/>
-            </a:pPr>
-            <a:r>
-              <a:rPr lang="en-US" sz="1200" b="1" spc="200" kern="0" dirty="0">
-                <a:solidFill>
-                  <a:srgbClr val="5B6478"/>
-                </a:solidFill>
-                <a:latin typeface="Calibri" pitchFamily="34" charset="0"/>
-                <a:ea typeface="Calibri" pitchFamily="34" charset="-122"/>
-                <a:cs typeface="Calibri" pitchFamily="34" charset="-120"/>
-              </a:rPr>
-              <a:t>SCOPE, AND WHAT I EXPECT TO DEFEND</a:t>
-            </a:r>
-            <a:endParaRPr lang="en-US" sz="1200" dirty="0"/>
-          </a:p>
-        </p:txBody>
-      </p:sp>
-      <p:sp>
-        <p:nvSpPr>
-          <p:cNvPr id="3" name="Text 1"/>
-          <p:cNvSpPr txBox="1"/>
-          <p:nvPr/>
-        </p:nvSpPr>
-        <p:spPr>
-          <a:xfrm>
-            <a:off x="548640" y="566928"/>
-            <a:ext cx="11064240" cy="640080"/>
-          </a:xfrm>
-          <a:prstGeom prst="rect">
-            <a:avLst/>
-          </a:prstGeom>
-          <a:noFill/>
-          <a:ln/>
-        </p:spPr>
-        <p:txBody>
-          <a:bodyPr wrap="square" lIns="0" tIns="0" rIns="0" bIns="0" rtlCol="0" anchor="ctr"/>
-          <a:lstStyle/>
-          <a:p>
-            <a:pPr indent="0" marL="0">
-              <a:buNone/>
-            </a:pPr>
-            <a:r>
-              <a:rPr lang="en-US" sz="2800" b="1" dirty="0">
-                <a:solidFill>
-                  <a:srgbClr val="1E2761"/>
-                </a:solidFill>
-                <a:latin typeface="Cambria" pitchFamily="34" charset="0"/>
-                <a:ea typeface="Cambria" pitchFamily="34" charset="-122"/>
-                <a:cs typeface="Cambria" pitchFamily="34" charset="-120"/>
-              </a:rPr>
-              <a:t>Ready for the first 30 minutes</a:t>
-            </a:r>
-            <a:endParaRPr lang="en-US" sz="2800" dirty="0"/>
-          </a:p>
-        </p:txBody>
-      </p:sp>
-      <p:sp>
-        <p:nvSpPr>
-          <p:cNvPr id="4" name="Shape 2"/>
-          <p:cNvSpPr/>
-          <p:nvPr/>
-        </p:nvSpPr>
-        <p:spPr>
-          <a:xfrm>
-            <a:off x="548640" y="1417320"/>
-            <a:ext cx="5440680" cy="4800600"/>
-          </a:xfrm>
-          <a:prstGeom prst="roundRect">
-            <a:avLst>
-              <a:gd name="adj" fmla="val 1905"/>
-            </a:avLst>
-          </a:prstGeom>
-          <a:solidFill>
-            <a:srgbClr val="F4F6FB"/>
-          </a:solidFill>
-          <a:ln w="12700">
-            <a:solidFill>
-              <a:srgbClr val="F4F6FB"/>
-            </a:solidFill>
-            <a:prstDash val="solid"/>
-          </a:ln>
-        </p:spPr>
-      </p:sp>
-      <p:sp>
-        <p:nvSpPr>
-          <p:cNvPr id="5" name="Text 3"/>
-          <p:cNvSpPr txBox="1"/>
-          <p:nvPr/>
-        </p:nvSpPr>
-        <p:spPr>
-          <a:xfrm>
-            <a:off x="822960" y="1645920"/>
-            <a:ext cx="4846320" cy="320040"/>
-          </a:xfrm>
-          <a:prstGeom prst="rect">
-            <a:avLst/>
-          </a:prstGeom>
-          <a:noFill/>
-          <a:ln/>
-        </p:spPr>
-        <p:txBody>
-          <a:bodyPr wrap="square" lIns="0" tIns="0" rIns="0" bIns="0" rtlCol="0" anchor="ctr"/>
-          <a:lstStyle/>
-          <a:p>
-            <a:pPr indent="0" marL="0">
-              <a:buNone/>
-            </a:pPr>
-            <a:r>
-              <a:rPr lang="en-US" sz="1400" b="1" dirty="0">
-                <a:solidFill>
-                  <a:srgbClr val="1E2761"/>
-                </a:solidFill>
-                <a:latin typeface="Calibri" pitchFamily="34" charset="0"/>
-                <a:ea typeface="Calibri" pitchFamily="34" charset="-122"/>
-                <a:cs typeface="Calibri" pitchFamily="34" charset="-120"/>
-              </a:rPr>
-              <a:t>Deliberately out of scope here</a:t>
-            </a:r>
-            <a:endParaRPr lang="en-US" sz="1400" dirty="0"/>
-          </a:p>
-        </p:txBody>
-      </p:sp>
-      <p:sp>
-        <p:nvSpPr>
-          <p:cNvPr id="6" name="Text 4"/>
-          <p:cNvSpPr txBox="1"/>
-          <p:nvPr/>
-        </p:nvSpPr>
-        <p:spPr>
-          <a:xfrm>
-            <a:off x="822960" y="2011680"/>
-            <a:ext cx="4846320" cy="1463040"/>
-          </a:xfrm>
-          <a:prstGeom prst="rect">
-            <a:avLst/>
-          </a:prstGeom>
-          <a:noFill/>
-          <a:ln/>
-        </p:spPr>
-        <p:txBody>
-          <a:bodyPr wrap="square" lIns="0" tIns="0" rIns="0" bIns="0" rtlCol="0" anchor="ctr"/>
-          <a:lstStyle/>
-          <a:p>
-            <a:pPr indent="0" marL="0">
-              <a:lnSpc>
-                <a:spcPct val="125000"/>
-              </a:lnSpc>
-              <a:buNone/>
-            </a:pPr>
-            <a:r>
-              <a:rPr lang="en-US" sz="1200" dirty="0">
-                <a:solidFill>
-                  <a:srgbClr val="1F2430"/>
-                </a:solidFill>
-                <a:latin typeface="Calibri" pitchFamily="34" charset="0"/>
-                <a:ea typeface="Calibri" pitchFamily="34" charset="-122"/>
-                <a:cs typeface="Calibri" pitchFamily="34" charset="-120"/>
-              </a:rPr>
-              <a:t>Region-loss DR (RTO/RPO target and its cost). Single-AZ resilience is the named constraint and is built into the network/compute design already — that's not DR, it's the baseline. Region failover is a real follow-up question with a verbal answer ready; it's kept out of the written artifact so it stays focused on what's asked.</a:t>
-            </a:r>
-            <a:endParaRPr lang="en-US" sz="1200" dirty="0"/>
-          </a:p>
-        </p:txBody>
-      </p:sp>
-      <p:sp>
-        <p:nvSpPr>
-          <p:cNvPr id="7" name="Text 5"/>
-          <p:cNvSpPr txBox="1"/>
-          <p:nvPr/>
-        </p:nvSpPr>
-        <p:spPr>
-          <a:xfrm>
-            <a:off x="822960" y="3611880"/>
-            <a:ext cx="4846320" cy="914400"/>
-          </a:xfrm>
-          <a:prstGeom prst="rect">
-            <a:avLst/>
-          </a:prstGeom>
-          <a:noFill/>
-          <a:ln/>
-        </p:spPr>
-        <p:txBody>
-          <a:bodyPr wrap="square" lIns="0" tIns="0" rIns="0" bIns="0" rtlCol="0" anchor="ctr"/>
-          <a:lstStyle/>
-          <a:p>
-            <a:pPr indent="0" marL="0">
-              <a:lnSpc>
-                <a:spcPct val="125000"/>
-              </a:lnSpc>
-              <a:buNone/>
-            </a:pPr>
-            <a:r>
-              <a:rPr lang="en-US" sz="1200" dirty="0">
-                <a:solidFill>
-                  <a:srgbClr val="1F2430"/>
-                </a:solidFill>
-                <a:latin typeface="Calibri" pitchFamily="34" charset="0"/>
-                <a:ea typeface="Calibri" pitchFamily="34" charset="-122"/>
-                <a:cs typeface="Calibri" pitchFamily="34" charset="-120"/>
-              </a:rPr>
-              <a:t>No internal 3GPP sub-function naming (AMF/SMF/UPF) in the diagrams — kept generic as “data-ingress” and “core-network” pods for a simpler conversation.</a:t>
-            </a:r>
-            <a:endParaRPr lang="en-US" sz="1200" dirty="0"/>
-          </a:p>
-        </p:txBody>
-      </p:sp>
-      <p:sp>
-        <p:nvSpPr>
-          <p:cNvPr id="8" name="Shape 6"/>
-          <p:cNvSpPr/>
-          <p:nvPr/>
-        </p:nvSpPr>
-        <p:spPr>
-          <a:xfrm>
-            <a:off x="6199632" y="1417320"/>
-            <a:ext cx="5440680" cy="4800600"/>
-          </a:xfrm>
-          <a:prstGeom prst="roundRect">
-            <a:avLst>
-              <a:gd name="adj" fmla="val 1905"/>
-            </a:avLst>
-          </a:prstGeom>
-          <a:solidFill>
-            <a:srgbClr val="1E2761"/>
-          </a:solidFill>
-          <a:ln w="12700">
-            <a:solidFill>
-              <a:srgbClr val="1E2761"/>
-            </a:solidFill>
-            <a:prstDash val="solid"/>
-          </a:ln>
-        </p:spPr>
-      </p:sp>
-      <p:sp>
-        <p:nvSpPr>
-          <p:cNvPr id="9" name="Text 7"/>
-          <p:cNvSpPr txBox="1"/>
-          <p:nvPr/>
-        </p:nvSpPr>
-        <p:spPr>
-          <a:xfrm>
-            <a:off x="6492240" y="1645920"/>
-            <a:ext cx="4846320" cy="320040"/>
-          </a:xfrm>
-          <a:prstGeom prst="rect">
-            <a:avLst/>
-          </a:prstGeom>
-          <a:noFill/>
-          <a:ln/>
-        </p:spPr>
-        <p:txBody>
-          <a:bodyPr wrap="square" lIns="0" tIns="0" rIns="0" bIns="0" rtlCol="0" anchor="ctr"/>
-          <a:lstStyle/>
-          <a:p>
-            <a:pPr indent="0" marL="0">
-              <a:buNone/>
-            </a:pPr>
-            <a:r>
-              <a:rPr lang="en-US" sz="1400" b="1" dirty="0">
-                <a:solidFill>
-                  <a:srgbClr val="FFFFFF"/>
-                </a:solidFill>
-                <a:latin typeface="Calibri" pitchFamily="34" charset="0"/>
-                <a:ea typeface="Calibri" pitchFamily="34" charset="-122"/>
-                <a:cs typeface="Calibri" pitchFamily="34" charset="-120"/>
-              </a:rPr>
-              <a:t>Trade-offs I'll defend if pushed</a:t>
-            </a:r>
-            <a:endParaRPr lang="en-US" sz="1400" dirty="0"/>
-          </a:p>
-        </p:txBody>
-      </p:sp>
-      <p:sp>
-        <p:nvSpPr>
-          <p:cNvPr id="10" name="Shape 8"/>
-          <p:cNvSpPr/>
-          <p:nvPr/>
-        </p:nvSpPr>
-        <p:spPr>
-          <a:xfrm>
-            <a:off x="6492240" y="2157984"/>
-            <a:ext cx="91440" cy="91440"/>
-          </a:xfrm>
-          <a:prstGeom prst="ellipse">
-            <a:avLst/>
-          </a:prstGeom>
-          <a:solidFill>
-            <a:srgbClr val="CADCFC"/>
-          </a:solidFill>
-          <a:ln w="12700">
-            <a:solidFill>
-              <a:srgbClr val="CADCFC"/>
-            </a:solidFill>
-            <a:prstDash val="solid"/>
-          </a:ln>
-        </p:spPr>
-      </p:sp>
-      <p:sp>
-        <p:nvSpPr>
-          <p:cNvPr id="11" name="Text 9"/>
-          <p:cNvSpPr txBox="1"/>
-          <p:nvPr/>
-        </p:nvSpPr>
-        <p:spPr>
-          <a:xfrm>
-            <a:off x="6766560" y="2029968"/>
-            <a:ext cx="4709160" cy="777240"/>
-          </a:xfrm>
-          <a:prstGeom prst="rect">
-            <a:avLst/>
-          </a:prstGeom>
-          <a:noFill/>
-          <a:ln/>
-        </p:spPr>
-        <p:txBody>
-          <a:bodyPr wrap="square" lIns="0" tIns="0" rIns="0" bIns="0" rtlCol="0" anchor="ctr"/>
-          <a:lstStyle/>
-          <a:p>
-            <a:pPr indent="0" marL="0">
-              <a:lnSpc>
-                <a:spcPct val="120000"/>
-              </a:lnSpc>
-              <a:buNone/>
-            </a:pPr>
-            <a:r>
-              <a:rPr lang="en-US" sz="1200" dirty="0">
-                <a:solidFill>
-                  <a:srgbClr val="FFFFFF"/>
-                </a:solidFill>
-                <a:latin typeface="Calibri" pitchFamily="34" charset="0"/>
-                <a:ea typeface="Calibri" pitchFamily="34" charset="-122"/>
-                <a:cs typeface="Calibri" pitchFamily="34" charset="-120"/>
-              </a:rPr>
-              <a:t>EKS over ECS — reverses if the workload turns out to be session/control-only.</a:t>
-            </a:r>
-            <a:endParaRPr lang="en-US" sz="1200" dirty="0"/>
-          </a:p>
-        </p:txBody>
-      </p:sp>
-      <p:sp>
-        <p:nvSpPr>
-          <p:cNvPr id="12" name="Shape 10"/>
-          <p:cNvSpPr/>
-          <p:nvPr/>
-        </p:nvSpPr>
-        <p:spPr>
-          <a:xfrm>
-            <a:off x="6492240" y="3026664"/>
-            <a:ext cx="91440" cy="91440"/>
-          </a:xfrm>
-          <a:prstGeom prst="ellipse">
-            <a:avLst/>
-          </a:prstGeom>
-          <a:solidFill>
-            <a:srgbClr val="CADCFC"/>
-          </a:solidFill>
-          <a:ln w="12700">
-            <a:solidFill>
-              <a:srgbClr val="CADCFC"/>
-            </a:solidFill>
-            <a:prstDash val="solid"/>
-          </a:ln>
-        </p:spPr>
-      </p:sp>
-      <p:sp>
-        <p:nvSpPr>
-          <p:cNvPr id="13" name="Text 11"/>
-          <p:cNvSpPr txBox="1"/>
-          <p:nvPr/>
-        </p:nvSpPr>
-        <p:spPr>
-          <a:xfrm>
-            <a:off x="6766560" y="2898648"/>
-            <a:ext cx="4709160" cy="777240"/>
-          </a:xfrm>
-          <a:prstGeom prst="rect">
-            <a:avLst/>
-          </a:prstGeom>
-          <a:noFill/>
-          <a:ln/>
-        </p:spPr>
-        <p:txBody>
-          <a:bodyPr wrap="square" lIns="0" tIns="0" rIns="0" bIns="0" rtlCol="0" anchor="ctr"/>
-          <a:lstStyle/>
-          <a:p>
-            <a:pPr indent="0" marL="0">
-              <a:lnSpc>
-                <a:spcPct val="120000"/>
-              </a:lnSpc>
-              <a:buNone/>
-            </a:pPr>
-            <a:r>
-              <a:rPr lang="en-US" sz="1200" dirty="0">
-                <a:solidFill>
-                  <a:srgbClr val="FFFFFF"/>
-                </a:solidFill>
-                <a:latin typeface="Calibri" pitchFamily="34" charset="0"/>
-                <a:ea typeface="Calibri" pitchFamily="34" charset="-122"/>
-                <a:cs typeface="Calibri" pitchFamily="34" charset="-120"/>
-              </a:rPr>
-              <a:t>TGW attachment in private subnets, no dedicated tgw-attach tier — reverses on a security review.</a:t>
-            </a:r>
-            <a:endParaRPr lang="en-US" sz="1200" dirty="0"/>
-          </a:p>
-        </p:txBody>
-      </p:sp>
-      <p:sp>
-        <p:nvSpPr>
-          <p:cNvPr id="14" name="Shape 12"/>
-          <p:cNvSpPr/>
-          <p:nvPr/>
-        </p:nvSpPr>
-        <p:spPr>
-          <a:xfrm>
-            <a:off x="6492240" y="3895344"/>
-            <a:ext cx="91440" cy="91440"/>
-          </a:xfrm>
-          <a:prstGeom prst="ellipse">
-            <a:avLst/>
-          </a:prstGeom>
-          <a:solidFill>
-            <a:srgbClr val="CADCFC"/>
-          </a:solidFill>
-          <a:ln w="12700">
-            <a:solidFill>
-              <a:srgbClr val="CADCFC"/>
-            </a:solidFill>
-            <a:prstDash val="solid"/>
-          </a:ln>
-        </p:spPr>
-      </p:sp>
-      <p:sp>
-        <p:nvSpPr>
-          <p:cNvPr id="15" name="Text 13"/>
-          <p:cNvSpPr txBox="1"/>
-          <p:nvPr/>
-        </p:nvSpPr>
-        <p:spPr>
-          <a:xfrm>
-            <a:off x="6766560" y="3767328"/>
-            <a:ext cx="4709160" cy="777240"/>
-          </a:xfrm>
-          <a:prstGeom prst="rect">
-            <a:avLst/>
-          </a:prstGeom>
-          <a:noFill/>
-          <a:ln/>
-        </p:spPr>
-        <p:txBody>
-          <a:bodyPr wrap="square" lIns="0" tIns="0" rIns="0" bIns="0" rtlCol="0" anchor="ctr"/>
-          <a:lstStyle/>
-          <a:p>
-            <a:pPr indent="0" marL="0">
-              <a:lnSpc>
-                <a:spcPct val="120000"/>
-              </a:lnSpc>
-              <a:buNone/>
-            </a:pPr>
-            <a:r>
-              <a:rPr lang="en-US" sz="1200" dirty="0">
-                <a:solidFill>
-                  <a:srgbClr val="FFFFFF"/>
-                </a:solidFill>
-                <a:latin typeface="Calibri" pitchFamily="34" charset="0"/>
-                <a:ea typeface="Calibri" pitchFamily="34" charset="-122"/>
-                <a:cs typeface="Calibri" pitchFamily="34" charset="-120"/>
-              </a:rPr>
-              <a:t>ElastiCache failover claim depends on the client library being cluster-aware — needs confirming.</a:t>
-            </a:r>
-            <a:endParaRPr lang="en-US" sz="1200" dirty="0"/>
-          </a:p>
-        </p:txBody>
-      </p:sp>
-      <p:sp>
-        <p:nvSpPr>
-          <p:cNvPr id="16" name="Shape 14"/>
-          <p:cNvSpPr/>
-          <p:nvPr/>
-        </p:nvSpPr>
-        <p:spPr>
-          <a:xfrm>
-            <a:off x="6492240" y="4764024"/>
-            <a:ext cx="91440" cy="91440"/>
-          </a:xfrm>
-          <a:prstGeom prst="ellipse">
-            <a:avLst/>
-          </a:prstGeom>
-          <a:solidFill>
-            <a:srgbClr val="CADCFC"/>
-          </a:solidFill>
-          <a:ln w="12700">
-            <a:solidFill>
-              <a:srgbClr val="CADCFC"/>
-            </a:solidFill>
-            <a:prstDash val="solid"/>
-          </a:ln>
-        </p:spPr>
-      </p:sp>
-      <p:sp>
-        <p:nvSpPr>
-          <p:cNvPr id="17" name="Text 15"/>
-          <p:cNvSpPr txBox="1"/>
-          <p:nvPr/>
-        </p:nvSpPr>
-        <p:spPr>
-          <a:xfrm>
-            <a:off x="6766560" y="4636008"/>
-            <a:ext cx="4709160" cy="777240"/>
-          </a:xfrm>
-          <a:prstGeom prst="rect">
-            <a:avLst/>
-          </a:prstGeom>
-          <a:noFill/>
-          <a:ln/>
-        </p:spPr>
-        <p:txBody>
-          <a:bodyPr wrap="square" lIns="0" tIns="0" rIns="0" bIns="0" rtlCol="0" anchor="ctr"/>
-          <a:lstStyle/>
-          <a:p>
-            <a:pPr indent="0" marL="0">
-              <a:lnSpc>
-                <a:spcPct val="120000"/>
-              </a:lnSpc>
-              <a:buNone/>
-            </a:pPr>
-            <a:r>
-              <a:rPr lang="en-US" sz="1200" dirty="0">
-                <a:solidFill>
-                  <a:srgbClr val="FFFFFF"/>
-                </a:solidFill>
-                <a:latin typeface="Calibri" pitchFamily="34" charset="0"/>
-                <a:ea typeface="Calibri" pitchFamily="34" charset="-122"/>
-                <a:cs typeface="Calibri" pitchFamily="34" charset="-120"/>
-              </a:rPr>
-              <a:t>Single Direct Connect circuit, as scoped — production hardening would add a second circuit.</a:t>
-            </a:r>
-            <a:endParaRPr lang="en-US" sz="1200" dirty="0"/>
-          </a:p>
-        </p:txBody>
-      </p:sp>
-      <p:sp>
-        <p:nvSpPr>
-          <p:cNvPr id="18" name="Text 16"/>
-          <p:cNvSpPr txBox="1"/>
-          <p:nvPr/>
-        </p:nvSpPr>
-        <p:spPr>
-          <a:xfrm>
-            <a:off x="548640" y="6528816"/>
-            <a:ext cx="7315200" cy="256032"/>
-          </a:xfrm>
-          <a:prstGeom prst="rect">
-            <a:avLst/>
-          </a:prstGeom>
-          <a:noFill/>
-          <a:ln/>
-        </p:spPr>
-        <p:txBody>
-          <a:bodyPr wrap="square" lIns="0" tIns="0" rIns="0" bIns="0" rtlCol="0" anchor="ctr"/>
-          <a:lstStyle/>
-          <a:p>
-            <a:pPr indent="0" marL="0">
-              <a:buNone/>
-            </a:pPr>
-            <a:r>
-              <a:rPr lang="en-US" sz="900" dirty="0">
-                <a:solidFill>
-                  <a:srgbClr val="5B6478"/>
-                </a:solidFill>
-                <a:latin typeface="Calibri" pitchFamily="34" charset="0"/>
-                <a:ea typeface="Calibri" pitchFamily="34" charset="-122"/>
-                <a:cs typeface="Calibri" pitchFamily="34" charset="-120"/>
-              </a:rPr>
-              <a:t>Skylo Regional Hub — AWS Architecture</a:t>
-            </a:r>
-            <a:endParaRPr lang="en-US" sz="900" dirty="0"/>
-          </a:p>
-        </p:txBody>
-      </p:sp>
-      <p:sp>
-        <p:nvSpPr>
-          <p:cNvPr id="19" name="Text 17"/>
-          <p:cNvSpPr txBox="1"/>
-          <p:nvPr/>
-        </p:nvSpPr>
-        <p:spPr>
-          <a:xfrm>
-            <a:off x="11521440" y="6528816"/>
-            <a:ext cx="365760" cy="256032"/>
-          </a:xfrm>
-          <a:prstGeom prst="rect">
-            <a:avLst/>
-          </a:prstGeom>
-          <a:noFill/>
-          <a:ln/>
-        </p:spPr>
-        <p:txBody>
-          <a:bodyPr wrap="square" lIns="0" tIns="0" rIns="0" bIns="0" rtlCol="0" anchor="ctr"/>
-          <a:lstStyle/>
-          <a:p>
-            <a:pPr algn="r" indent="0" marL="0">
-              <a:buNone/>
-            </a:pPr>
-            <a:r>
-              <a:rPr lang="en-US" sz="900" dirty="0">
-                <a:solidFill>
-                  <a:srgbClr val="5B6478"/>
-                </a:solidFill>
-                <a:latin typeface="Calibri" pitchFamily="34" charset="0"/>
-                <a:ea typeface="Calibri" pitchFamily="34" charset="-122"/>
-                <a:cs typeface="Calibri" pitchFamily="34" charset="-120"/>
-              </a:rPr>
-              <a:t>11</a:t>
-            </a:r>
-            <a:endParaRPr lang="en-US" sz="900" dirty="0"/>
-          </a:p>
-        </p:txBody>
-      </p:sp>
-    </p:spTree>
-  </p:cSld>
-  <p:clrMapOvr>
-    <a:masterClrMapping/>
-  </p:clrMapOvr>
-</p:sld>
-</file>
-
-<file path=ppt/slides/slide12.xml><?xml version="1.0" encoding="utf-8"?>
-<p:sld xmlns:a="http://schemas.openxmlformats.org/drawingml/2006/main" xmlns:r="http://schemas.openxmlformats.org/officeDocument/2006/relationships" xmlns:p="http://schemas.openxmlformats.org/presentationml/2006/main">
-  <p:cSld name="Slide 12">
     <p:bg>
       <p:bgPr>
         <a:solidFill>
@@ -3612,7 +2723,7 @@
                 <a:ea typeface="Calibri" pitchFamily="34" charset="-122"/>
                 <a:cs typeface="Calibri" pitchFamily="34" charset="-120"/>
               </a:rPr>
-              <a:t>NETWORK-DESIGN.md  ·  DESIGN.md  ·  vpc.md</a:t>
+              <a:t>NETWORK-DESIGN.md  ·  DESIGN.md  ·  vpc.md  ·  vpc.tf</a:t>
             </a:r>
             <a:endParaRPr lang="en-US" sz="1400" dirty="0"/>
           </a:p>
@@ -5492,7 +4603,7 @@
                 <a:ea typeface="Calibri" pitchFamily="34" charset="-122"/>
                 <a:cs typeface="Calibri" pitchFamily="34" charset="-120"/>
               </a:rPr>
-              <a:t>The bug this replaces</a:t>
+              <a:t>Why this holds as Skylo scales</a:t>
             </a:r>
             <a:endParaRPr lang="en-US" sz="1300" dirty="0"/>
           </a:p>
@@ -5534,7 +4645,7 @@
                 <a:ea typeface="Calibri" pitchFamily="34" charset="-122"/>
                 <a:cs typeface="Calibri" pitchFamily="34" charset="-120"/>
               </a:rPr>
-              <a:t>An earlier placeholder used 10.96.0.0/11 for org CIDRs — which actually overlaps 10.100.0.0/16, the hub's own VPC. AWS's implicit local-route precedence hides the symptom, but it directly contradicts the “no collisions as we add hubs” claim. Three disjoint address families close it structurally: hub ≠ ground ≠ org, permanently.</a:t>
+              <a:t>Hub VPCs and ground segments are two halves of the same /8 — deliberately chosen so neither can ever grow into the other. Org accounts sit in a different RFC1918 block altogether. That's a structural property, not a naming convention someone has to keep enforcing correctly: adding hub #37 tomorrow cannot collide with any existing hub's ground segment or any org account, by construction.</a:t>
             </a:r>
             <a:endParaRPr lang="en-US" sz="1200" dirty="0"/>
           </a:p>
@@ -6492,7 +5603,7 @@
                 <a:ea typeface="Calibri" pitchFamily="34" charset="-122"/>
                 <a:cs typeface="Calibri" pitchFamily="34" charset="-120"/>
               </a:rPr>
-              <a:t>Session/application processing time is counted separately — it's workload-dependent, not a network number. And these are order-of-magnitude engineering estimates from AWS's published component characteristics, not benchmarked figures. Conflating illustrative numbers with measured SLIs is exactly the mistake this design avoids repeating.</a:t>
+              <a:t>Session/application processing time is counted separately — it's workload-dependent, not a network number. And these are order-of-magnitude engineering estimates from AWS's published component characteristics, not benchmarked figures — stated as ranges on purpose rather than a false-precision single number.</a:t>
             </a:r>
             <a:endParaRPr lang="en-US" sz="1250" dirty="0"/>
           </a:p>

</xml_diff>